<commit_message>
Switch animations to auto-play: sections fade in automatically
Each slide's content now fades in automatically without clicking:
- First group appears 400ms after landing on the slide
- Each subsequent group fades in 300ms after the previous finishes
- 500ms smooth fade duration per group

No more Enter/click needed — just advance slides and watch
the content build itself.

Co-Authored-By: Claude Opus 4.6 <noreply@anthropic.com>
Claude-Session: https://claude.ai/code/session_01VwAEL1gh5GSVVNQtLSuyYj
</commit_message>
<xml_diff>
--- a/Elevate-Vision-2027.pptx
+++ b/Elevate-Vision-2027.pptx
@@ -115,47 +115,47 @@
   <p:extLst>
     <p:ext uri="{521415D9-36F7-43E2-AB2F-B90AF26B5E84}">
       <p14:sectionLst xmlns:p14="http://schemas.microsoft.com/office/powerpoint/2010/main">
-        <p14:section name="Opening" id="{b1933991-12ed-8ec3-8137-8b40d45c997a}">
+        <p14:section name="Opening" id="{80ac147a-5d73-75dc-4b39-78e434a65c33}">
           <p14:sldIdLst>
             <p14:sldId id="256"/>
           </p14:sldIdLst>
         </p14:section>
-        <p14:section name="Vision" id="{45485ebd-ea18-a173-9d0e-214f3dc87c9a}">
+        <p14:section name="Vision" id="{4008b90c-02a6-32a7-41ef-a5902bbcd471}">
           <p14:sldIdLst>
             <p14:sldId id="257"/>
           </p14:sldIdLst>
         </p14:section>
-        <p14:section name="Metrics" id="{3a1733c3-3a1c-fdc1-81b1-4feea41fa72a}">
+        <p14:section name="Metrics" id="{f16d59d5-9f0f-894e-d214-f936b0af6e61}">
           <p14:sldIdLst>
             <p14:sldId id="258"/>
           </p14:sldIdLst>
         </p14:section>
-        <p14:section name="Market" id="{46739440-883c-6924-9c46-77b914be32c5}">
+        <p14:section name="Market" id="{b7827484-4ece-d663-8b0a-f3d64683df3f}">
           <p14:sldIdLst>
             <p14:sldId id="259"/>
           </p14:sldIdLst>
         </p14:section>
-        <p14:section name="Strategy" id="{04eeda06-1e4a-119b-261e-2842d0014de5}">
+        <p14:section name="Strategy" id="{8d0fca0e-ece9-2a54-ba19-3cc58708b472}">
           <p14:sldIdLst>
             <p14:sldId id="260"/>
           </p14:sldIdLst>
         </p14:section>
-        <p14:section name="Roadmap" id="{f9986d98-a67f-b78d-99a3-ddbe932d6b16}">
+        <p14:section name="Roadmap" id="{3b1981b7-124d-325d-4d4e-707db3637183}">
           <p14:sldIdLst>
             <p14:sldId id="261"/>
           </p14:sldIdLst>
         </p14:section>
-        <p14:section name="Results" id="{9c2b5db6-4075-3c4c-5eef-287d170ea51a}">
+        <p14:section name="Results" id="{d3b9cff6-6b1a-0288-ed0e-3bc9a41630ef}">
           <p14:sldIdLst>
             <p14:sldId id="262"/>
           </p14:sldIdLst>
         </p14:section>
-        <p14:section name="Next Steps" id="{0b0a23eb-0dbf-0625-6048-288309f2eadc}">
+        <p14:section name="Next Steps" id="{7e69a90b-2a2a-ae2f-435b-d62de7504904}">
           <p14:sldIdLst>
             <p14:sldId id="263"/>
           </p14:sldIdLst>
         </p14:section>
-        <p14:section name="Close" id="{d239fdc5-4093-6c46-ece3-d53949d2fb3b}">
+        <p14:section name="Close" id="{50b70c14-7085-6669-f84f-179728bc5b86}">
           <p14:sldIdLst>
             <p14:sldId id="264"/>
           </p14:sldIdLst>
@@ -2795,7 +2795,7 @@
                   <p:par>
                     <p:cTn id="3" fill="hold">
                       <p:stCondLst>
-                        <p:cond delay="indefinite"/>
+                        <p:cond delay="400"/>
                       </p:stCondLst>
                       <p:childTnLst>
                         <p:par>
@@ -2805,7 +2805,7 @@
                             </p:stCondLst>
                             <p:childTnLst>
                               <p:par>
-                                <p:cTn id="5" presetID="10" presetClass="entr" presetSubtype="0" fill="hold" grpId="0" nodeType="clickEffect">
+                                <p:cTn id="5" presetID="10" presetClass="entr" presetSubtype="0" fill="hold" grpId="0" nodeType="afterEffect">
                                   <p:stCondLst>
                                     <p:cond delay="0"/>
                                   </p:stCondLst>
@@ -2892,7 +2892,7 @@
                   <p:par>
                     <p:cTn id="12" fill="hold">
                       <p:stCondLst>
-                        <p:cond delay="indefinite"/>
+                        <p:cond delay="300"/>
                       </p:stCondLst>
                       <p:childTnLst>
                         <p:par>
@@ -2902,7 +2902,7 @@
                             </p:stCondLst>
                             <p:childTnLst>
                               <p:par>
-                                <p:cTn id="14" presetID="10" presetClass="entr" presetSubtype="0" fill="hold" grpId="0" nodeType="clickEffect">
+                                <p:cTn id="14" presetID="10" presetClass="entr" presetSubtype="0" fill="hold" grpId="0" nodeType="afterEffect">
                                   <p:stCondLst>
                                     <p:cond delay="0"/>
                                   </p:stCondLst>
@@ -3710,7 +3710,7 @@
                   <p:par>
                     <p:cTn id="3" fill="hold">
                       <p:stCondLst>
-                        <p:cond delay="indefinite"/>
+                        <p:cond delay="400"/>
                       </p:stCondLst>
                       <p:childTnLst>
                         <p:par>
@@ -3720,7 +3720,7 @@
                             </p:stCondLst>
                             <p:childTnLst>
                               <p:par>
-                                <p:cTn id="5" presetID="10" presetClass="entr" presetSubtype="0" fill="hold" grpId="0" nodeType="clickEffect">
+                                <p:cTn id="5" presetID="10" presetClass="entr" presetSubtype="0" fill="hold" grpId="0" nodeType="afterEffect">
                                   <p:stCondLst>
                                     <p:cond delay="0"/>
                                   </p:stCondLst>
@@ -3807,7 +3807,7 @@
                   <p:par>
                     <p:cTn id="12" fill="hold">
                       <p:stCondLst>
-                        <p:cond delay="indefinite"/>
+                        <p:cond delay="300"/>
                       </p:stCondLst>
                       <p:childTnLst>
                         <p:par>
@@ -3817,7 +3817,7 @@
                             </p:stCondLst>
                             <p:childTnLst>
                               <p:par>
-                                <p:cTn id="14" presetID="10" presetClass="entr" presetSubtype="0" fill="hold" grpId="0" nodeType="clickEffect">
+                                <p:cTn id="14" presetID="10" presetClass="entr" presetSubtype="0" fill="hold" grpId="0" nodeType="afterEffect">
                                   <p:stCondLst>
                                     <p:cond delay="0"/>
                                   </p:stCondLst>
@@ -4036,7 +4036,7 @@
                   <p:par>
                     <p:cTn id="33" fill="hold">
                       <p:stCondLst>
-                        <p:cond delay="indefinite"/>
+                        <p:cond delay="300"/>
                       </p:stCondLst>
                       <p:childTnLst>
                         <p:par>
@@ -4046,7 +4046,7 @@
                             </p:stCondLst>
                             <p:childTnLst>
                               <p:par>
-                                <p:cTn id="35" presetID="10" presetClass="entr" presetSubtype="0" fill="hold" grpId="0" nodeType="clickEffect">
+                                <p:cTn id="35" presetID="10" presetClass="entr" presetSubtype="0" fill="hold" grpId="0" nodeType="afterEffect">
                                   <p:stCondLst>
                                     <p:cond delay="0"/>
                                   </p:stCondLst>
@@ -4265,7 +4265,7 @@
                   <p:par>
                     <p:cTn id="54" fill="hold">
                       <p:stCondLst>
-                        <p:cond delay="indefinite"/>
+                        <p:cond delay="300"/>
                       </p:stCondLst>
                       <p:childTnLst>
                         <p:par>
@@ -4275,7 +4275,7 @@
                             </p:stCondLst>
                             <p:childTnLst>
                               <p:par>
-                                <p:cTn id="56" presetID="10" presetClass="entr" presetSubtype="0" fill="hold" grpId="0" nodeType="clickEffect">
+                                <p:cTn id="56" presetID="10" presetClass="entr" presetSubtype="0" fill="hold" grpId="0" nodeType="afterEffect">
                                   <p:stCondLst>
                                     <p:cond delay="0"/>
                                   </p:stCondLst>
@@ -5471,7 +5471,7 @@
                   <p:par>
                     <p:cTn id="3" fill="hold">
                       <p:stCondLst>
-                        <p:cond delay="indefinite"/>
+                        <p:cond delay="400"/>
                       </p:stCondLst>
                       <p:childTnLst>
                         <p:par>
@@ -5481,7 +5481,7 @@
                             </p:stCondLst>
                             <p:childTnLst>
                               <p:par>
-                                <p:cTn id="5" presetID="10" presetClass="entr" presetSubtype="0" fill="hold" grpId="0" nodeType="clickEffect">
+                                <p:cTn id="5" presetID="10" presetClass="entr" presetSubtype="0" fill="hold" grpId="0" nodeType="afterEffect">
                                   <p:stCondLst>
                                     <p:cond delay="0"/>
                                   </p:stCondLst>
@@ -5568,7 +5568,7 @@
                   <p:par>
                     <p:cTn id="12" fill="hold">
                       <p:stCondLst>
-                        <p:cond delay="indefinite"/>
+                        <p:cond delay="300"/>
                       </p:stCondLst>
                       <p:childTnLst>
                         <p:par>
@@ -5578,7 +5578,7 @@
                             </p:stCondLst>
                             <p:childTnLst>
                               <p:par>
-                                <p:cTn id="14" presetID="10" presetClass="entr" presetSubtype="0" fill="hold" grpId="0" nodeType="clickEffect">
+                                <p:cTn id="14" presetID="10" presetClass="entr" presetSubtype="0" fill="hold" grpId="0" nodeType="afterEffect">
                                   <p:stCondLst>
                                     <p:cond delay="0"/>
                                   </p:stCondLst>
@@ -5841,7 +5841,7 @@
                   <p:par>
                     <p:cTn id="37" fill="hold">
                       <p:stCondLst>
-                        <p:cond delay="indefinite"/>
+                        <p:cond delay="300"/>
                       </p:stCondLst>
                       <p:childTnLst>
                         <p:par>
@@ -5851,7 +5851,7 @@
                             </p:stCondLst>
                             <p:childTnLst>
                               <p:par>
-                                <p:cTn id="39" presetID="10" presetClass="entr" presetSubtype="0" fill="hold" grpId="0" nodeType="clickEffect">
+                                <p:cTn id="39" presetID="10" presetClass="entr" presetSubtype="0" fill="hold" grpId="0" nodeType="afterEffect">
                                   <p:stCondLst>
                                     <p:cond delay="0"/>
                                   </p:stCondLst>
@@ -6114,7 +6114,7 @@
                   <p:par>
                     <p:cTn id="62" fill="hold">
                       <p:stCondLst>
-                        <p:cond delay="indefinite"/>
+                        <p:cond delay="300"/>
                       </p:stCondLst>
                       <p:childTnLst>
                         <p:par>
@@ -6124,7 +6124,7 @@
                             </p:stCondLst>
                             <p:childTnLst>
                               <p:par>
-                                <p:cTn id="64" presetID="10" presetClass="entr" presetSubtype="0" fill="hold" grpId="0" nodeType="clickEffect">
+                                <p:cTn id="64" presetID="10" presetClass="entr" presetSubtype="0" fill="hold" grpId="0" nodeType="afterEffect">
                                   <p:stCondLst>
                                     <p:cond delay="0"/>
                                   </p:stCondLst>
@@ -6387,7 +6387,7 @@
                   <p:par>
                     <p:cTn id="87" fill="hold">
                       <p:stCondLst>
-                        <p:cond delay="indefinite"/>
+                        <p:cond delay="300"/>
                       </p:stCondLst>
                       <p:childTnLst>
                         <p:par>
@@ -6397,7 +6397,7 @@
                             </p:stCondLst>
                             <p:childTnLst>
                               <p:par>
-                                <p:cTn id="89" presetID="10" presetClass="entr" presetSubtype="0" fill="hold" grpId="0" nodeType="clickEffect">
+                                <p:cTn id="89" presetID="10" presetClass="entr" presetSubtype="0" fill="hold" grpId="0" nodeType="afterEffect">
                                   <p:stCondLst>
                                     <p:cond delay="0"/>
                                   </p:stCondLst>
@@ -7182,7 +7182,7 @@
                   <p:par>
                     <p:cTn id="3" fill="hold">
                       <p:stCondLst>
-                        <p:cond delay="indefinite"/>
+                        <p:cond delay="400"/>
                       </p:stCondLst>
                       <p:childTnLst>
                         <p:par>
@@ -7192,7 +7192,7 @@
                             </p:stCondLst>
                             <p:childTnLst>
                               <p:par>
-                                <p:cTn id="5" presetID="10" presetClass="entr" presetSubtype="0" fill="hold" grpId="0" nodeType="clickEffect">
+                                <p:cTn id="5" presetID="10" presetClass="entr" presetSubtype="0" fill="hold" grpId="0" nodeType="afterEffect">
                                   <p:stCondLst>
                                     <p:cond delay="0"/>
                                   </p:stCondLst>
@@ -7235,7 +7235,7 @@
                   <p:par>
                     <p:cTn id="8" fill="hold">
                       <p:stCondLst>
-                        <p:cond delay="indefinite"/>
+                        <p:cond delay="300"/>
                       </p:stCondLst>
                       <p:childTnLst>
                         <p:par>
@@ -7245,7 +7245,7 @@
                             </p:stCondLst>
                             <p:childTnLst>
                               <p:par>
-                                <p:cTn id="10" presetID="10" presetClass="entr" presetSubtype="0" fill="hold" grpId="0" nodeType="clickEffect">
+                                <p:cTn id="10" presetID="10" presetClass="entr" presetSubtype="0" fill="hold" grpId="0" nodeType="afterEffect">
                                   <p:stCondLst>
                                     <p:cond delay="0"/>
                                   </p:stCondLst>
@@ -7288,7 +7288,7 @@
                   <p:par>
                     <p:cTn id="13" fill="hold">
                       <p:stCondLst>
-                        <p:cond delay="indefinite"/>
+                        <p:cond delay="300"/>
                       </p:stCondLst>
                       <p:childTnLst>
                         <p:par>
@@ -7298,7 +7298,7 @@
                             </p:stCondLst>
                             <p:childTnLst>
                               <p:par>
-                                <p:cTn id="15" presetID="10" presetClass="entr" presetSubtype="0" fill="hold" grpId="0" nodeType="clickEffect">
+                                <p:cTn id="15" presetID="10" presetClass="entr" presetSubtype="0" fill="hold" grpId="0" nodeType="afterEffect">
                                   <p:stCondLst>
                                     <p:cond delay="0"/>
                                   </p:stCondLst>
@@ -8615,7 +8615,7 @@
                   <p:par>
                     <p:cTn id="3" fill="hold">
                       <p:stCondLst>
-                        <p:cond delay="indefinite"/>
+                        <p:cond delay="400"/>
                       </p:stCondLst>
                       <p:childTnLst>
                         <p:par>
@@ -8625,7 +8625,7 @@
                             </p:stCondLst>
                             <p:childTnLst>
                               <p:par>
-                                <p:cTn id="5" presetID="10" presetClass="entr" presetSubtype="0" fill="hold" grpId="0" nodeType="clickEffect">
+                                <p:cTn id="5" presetID="10" presetClass="entr" presetSubtype="0" fill="hold" grpId="0" nodeType="afterEffect">
                                   <p:stCondLst>
                                     <p:cond delay="0"/>
                                   </p:stCondLst>
@@ -8712,7 +8712,7 @@
                   <p:par>
                     <p:cTn id="12" fill="hold">
                       <p:stCondLst>
-                        <p:cond delay="indefinite"/>
+                        <p:cond delay="300"/>
                       </p:stCondLst>
                       <p:childTnLst>
                         <p:par>
@@ -8722,7 +8722,7 @@
                             </p:stCondLst>
                             <p:childTnLst>
                               <p:par>
-                                <p:cTn id="14" presetID="10" presetClass="entr" presetSubtype="0" fill="hold" grpId="0" nodeType="clickEffect">
+                                <p:cTn id="14" presetID="10" presetClass="entr" presetSubtype="0" fill="hold" grpId="0" nodeType="afterEffect">
                                   <p:stCondLst>
                                     <p:cond delay="0"/>
                                   </p:stCondLst>
@@ -9161,7 +9161,7 @@
                   <p:par>
                     <p:cTn id="53" fill="hold">
                       <p:stCondLst>
-                        <p:cond delay="indefinite"/>
+                        <p:cond delay="300"/>
                       </p:stCondLst>
                       <p:childTnLst>
                         <p:par>
@@ -9171,7 +9171,7 @@
                             </p:stCondLst>
                             <p:childTnLst>
                               <p:par>
-                                <p:cTn id="55" presetID="10" presetClass="entr" presetSubtype="0" fill="hold" grpId="0" nodeType="clickEffect">
+                                <p:cTn id="55" presetID="10" presetClass="entr" presetSubtype="0" fill="hold" grpId="0" nodeType="afterEffect">
                                   <p:stCondLst>
                                     <p:cond delay="0"/>
                                   </p:stCondLst>
@@ -10765,7 +10765,7 @@
                   <p:par>
                     <p:cTn id="3" fill="hold">
                       <p:stCondLst>
-                        <p:cond delay="indefinite"/>
+                        <p:cond delay="400"/>
                       </p:stCondLst>
                       <p:childTnLst>
                         <p:par>
@@ -10775,7 +10775,7 @@
                             </p:stCondLst>
                             <p:childTnLst>
                               <p:par>
-                                <p:cTn id="5" presetID="10" presetClass="entr" presetSubtype="0" fill="hold" grpId="0" nodeType="clickEffect">
+                                <p:cTn id="5" presetID="10" presetClass="entr" presetSubtype="0" fill="hold" grpId="0" nodeType="afterEffect">
                                   <p:stCondLst>
                                     <p:cond delay="0"/>
                                   </p:stCondLst>
@@ -10862,7 +10862,7 @@
                   <p:par>
                     <p:cTn id="12" fill="hold">
                       <p:stCondLst>
-                        <p:cond delay="indefinite"/>
+                        <p:cond delay="300"/>
                       </p:stCondLst>
                       <p:childTnLst>
                         <p:par>
@@ -10872,7 +10872,7 @@
                             </p:stCondLst>
                             <p:childTnLst>
                               <p:par>
-                                <p:cTn id="14" presetID="10" presetClass="entr" presetSubtype="0" fill="hold" grpId="0" nodeType="clickEffect">
+                                <p:cTn id="14" presetID="10" presetClass="entr" presetSubtype="0" fill="hold" grpId="0" nodeType="afterEffect">
                                   <p:stCondLst>
                                     <p:cond delay="0"/>
                                   </p:stCondLst>
@@ -11179,7 +11179,7 @@
                   <p:par>
                     <p:cTn id="41" fill="hold">
                       <p:stCondLst>
-                        <p:cond delay="indefinite"/>
+                        <p:cond delay="300"/>
                       </p:stCondLst>
                       <p:childTnLst>
                         <p:par>
@@ -11189,7 +11189,7 @@
                             </p:stCondLst>
                             <p:childTnLst>
                               <p:par>
-                                <p:cTn id="43" presetID="10" presetClass="entr" presetSubtype="0" fill="hold" grpId="0" nodeType="clickEffect">
+                                <p:cTn id="43" presetID="10" presetClass="entr" presetSubtype="0" fill="hold" grpId="0" nodeType="afterEffect">
                                   <p:stCondLst>
                                     <p:cond delay="0"/>
                                   </p:stCondLst>
@@ -11496,7 +11496,7 @@
                   <p:par>
                     <p:cTn id="70" fill="hold">
                       <p:stCondLst>
-                        <p:cond delay="indefinite"/>
+                        <p:cond delay="300"/>
                       </p:stCondLst>
                       <p:childTnLst>
                         <p:par>
@@ -11506,7 +11506,7 @@
                             </p:stCondLst>
                             <p:childTnLst>
                               <p:par>
-                                <p:cTn id="72" presetID="10" presetClass="entr" presetSubtype="0" fill="hold" grpId="0" nodeType="clickEffect">
+                                <p:cTn id="72" presetID="10" presetClass="entr" presetSubtype="0" fill="hold" grpId="0" nodeType="afterEffect">
                                   <p:stCondLst>
                                     <p:cond delay="0"/>
                                   </p:stCondLst>
@@ -11813,7 +11813,7 @@
                   <p:par>
                     <p:cTn id="99" fill="hold">
                       <p:stCondLst>
-                        <p:cond delay="indefinite"/>
+                        <p:cond delay="300"/>
                       </p:stCondLst>
                       <p:childTnLst>
                         <p:par>
@@ -11823,7 +11823,7 @@
                             </p:stCondLst>
                             <p:childTnLst>
                               <p:par>
-                                <p:cTn id="101" presetID="10" presetClass="entr" presetSubtype="0" fill="hold" grpId="0" nodeType="clickEffect">
+                                <p:cTn id="101" presetID="10" presetClass="entr" presetSubtype="0" fill="hold" grpId="0" nodeType="afterEffect">
                                   <p:stCondLst>
                                     <p:cond delay="0"/>
                                   </p:stCondLst>
@@ -12755,7 +12755,7 @@
                   <p:par>
                     <p:cTn id="3" fill="hold">
                       <p:stCondLst>
-                        <p:cond delay="indefinite"/>
+                        <p:cond delay="400"/>
                       </p:stCondLst>
                       <p:childTnLst>
                         <p:par>
@@ -12765,7 +12765,7 @@
                             </p:stCondLst>
                             <p:childTnLst>
                               <p:par>
-                                <p:cTn id="5" presetID="10" presetClass="entr" presetSubtype="0" fill="hold" grpId="0" nodeType="clickEffect">
+                                <p:cTn id="5" presetID="10" presetClass="entr" presetSubtype="0" fill="hold" grpId="0" nodeType="afterEffect">
                                   <p:stCondLst>
                                     <p:cond delay="0"/>
                                   </p:stCondLst>
@@ -12808,7 +12808,7 @@
                   <p:par>
                     <p:cTn id="8" fill="hold">
                       <p:stCondLst>
-                        <p:cond delay="indefinite"/>
+                        <p:cond delay="300"/>
                       </p:stCondLst>
                       <p:childTnLst>
                         <p:par>
@@ -12818,7 +12818,7 @@
                             </p:stCondLst>
                             <p:childTnLst>
                               <p:par>
-                                <p:cTn id="10" presetID="10" presetClass="entr" presetSubtype="0" fill="hold" grpId="0" nodeType="clickEffect">
+                                <p:cTn id="10" presetID="10" presetClass="entr" presetSubtype="0" fill="hold" grpId="0" nodeType="afterEffect">
                                   <p:stCondLst>
                                     <p:cond delay="0"/>
                                   </p:stCondLst>
@@ -12861,7 +12861,7 @@
                   <p:par>
                     <p:cTn id="13" fill="hold">
                       <p:stCondLst>
-                        <p:cond delay="indefinite"/>
+                        <p:cond delay="300"/>
                       </p:stCondLst>
                       <p:childTnLst>
                         <p:par>
@@ -12871,7 +12871,7 @@
                             </p:stCondLst>
                             <p:childTnLst>
                               <p:par>
-                                <p:cTn id="15" presetID="10" presetClass="entr" presetSubtype="0" fill="hold" grpId="0" nodeType="clickEffect">
+                                <p:cTn id="15" presetID="10" presetClass="entr" presetSubtype="0" fill="hold" grpId="0" nodeType="afterEffect">
                                   <p:stCondLst>
                                     <p:cond delay="0"/>
                                   </p:stCondLst>
@@ -14517,7 +14517,7 @@
                   <p:par>
                     <p:cTn id="3" fill="hold">
                       <p:stCondLst>
-                        <p:cond delay="indefinite"/>
+                        <p:cond delay="400"/>
                       </p:stCondLst>
                       <p:childTnLst>
                         <p:par>
@@ -14527,7 +14527,7 @@
                             </p:stCondLst>
                             <p:childTnLst>
                               <p:par>
-                                <p:cTn id="5" presetID="10" presetClass="entr" presetSubtype="0" fill="hold" grpId="0" nodeType="clickEffect">
+                                <p:cTn id="5" presetID="10" presetClass="entr" presetSubtype="0" fill="hold" grpId="0" nodeType="afterEffect">
                                   <p:stCondLst>
                                     <p:cond delay="0"/>
                                   </p:stCondLst>
@@ -14614,7 +14614,7 @@
                   <p:par>
                     <p:cTn id="12" fill="hold">
                       <p:stCondLst>
-                        <p:cond delay="indefinite"/>
+                        <p:cond delay="300"/>
                       </p:stCondLst>
                       <p:childTnLst>
                         <p:par>
@@ -14624,7 +14624,7 @@
                             </p:stCondLst>
                             <p:childTnLst>
                               <p:par>
-                                <p:cTn id="14" presetID="10" presetClass="entr" presetSubtype="0" fill="hold" grpId="0" nodeType="clickEffect">
+                                <p:cTn id="14" presetID="10" presetClass="entr" presetSubtype="0" fill="hold" grpId="0" nodeType="afterEffect">
                                   <p:stCondLst>
                                     <p:cond delay="0"/>
                                   </p:stCondLst>
@@ -14887,7 +14887,7 @@
                   <p:par>
                     <p:cTn id="37" fill="hold">
                       <p:stCondLst>
-                        <p:cond delay="indefinite"/>
+                        <p:cond delay="300"/>
                       </p:stCondLst>
                       <p:childTnLst>
                         <p:par>
@@ -14897,7 +14897,7 @@
                             </p:stCondLst>
                             <p:childTnLst>
                               <p:par>
-                                <p:cTn id="39" presetID="10" presetClass="entr" presetSubtype="0" fill="hold" grpId="0" nodeType="clickEffect">
+                                <p:cTn id="39" presetID="10" presetClass="entr" presetSubtype="0" fill="hold" grpId="0" nodeType="afterEffect">
                                   <p:stCondLst>
                                     <p:cond delay="0"/>
                                   </p:stCondLst>
@@ -15160,7 +15160,7 @@
                   <p:par>
                     <p:cTn id="62" fill="hold">
                       <p:stCondLst>
-                        <p:cond delay="indefinite"/>
+                        <p:cond delay="300"/>
                       </p:stCondLst>
                       <p:childTnLst>
                         <p:par>
@@ -15170,7 +15170,7 @@
                             </p:stCondLst>
                             <p:childTnLst>
                               <p:par>
-                                <p:cTn id="64" presetID="10" presetClass="entr" presetSubtype="0" fill="hold" grpId="0" nodeType="clickEffect">
+                                <p:cTn id="64" presetID="10" presetClass="entr" presetSubtype="0" fill="hold" grpId="0" nodeType="afterEffect">
                                   <p:stCondLst>
                                     <p:cond delay="0"/>
                                   </p:stCondLst>
@@ -15433,7 +15433,7 @@
                   <p:par>
                     <p:cTn id="87" fill="hold">
                       <p:stCondLst>
-                        <p:cond delay="indefinite"/>
+                        <p:cond delay="300"/>
                       </p:stCondLst>
                       <p:childTnLst>
                         <p:par>
@@ -15443,7 +15443,7 @@
                             </p:stCondLst>
                             <p:childTnLst>
                               <p:par>
-                                <p:cTn id="89" presetID="10" presetClass="entr" presetSubtype="0" fill="hold" grpId="0" nodeType="clickEffect">
+                                <p:cTn id="89" presetID="10" presetClass="entr" presetSubtype="0" fill="hold" grpId="0" nodeType="afterEffect">
                                   <p:stCondLst>
                                     <p:cond delay="0"/>
                                   </p:stCondLst>
@@ -16205,7 +16205,7 @@
                   <p:par>
                     <p:cTn id="3" fill="hold">
                       <p:stCondLst>
-                        <p:cond delay="indefinite"/>
+                        <p:cond delay="400"/>
                       </p:stCondLst>
                       <p:childTnLst>
                         <p:par>
@@ -16215,7 +16215,7 @@
                             </p:stCondLst>
                             <p:childTnLst>
                               <p:par>
-                                <p:cTn id="5" presetID="10" presetClass="entr" presetSubtype="0" fill="hold" grpId="0" nodeType="clickEffect">
+                                <p:cTn id="5" presetID="10" presetClass="entr" presetSubtype="0" fill="hold" grpId="0" nodeType="afterEffect">
                                   <p:stCondLst>
                                     <p:cond delay="0"/>
                                   </p:stCondLst>
@@ -16302,7 +16302,7 @@
                   <p:par>
                     <p:cTn id="12" fill="hold">
                       <p:stCondLst>
-                        <p:cond delay="indefinite"/>
+                        <p:cond delay="300"/>
                       </p:stCondLst>
                       <p:childTnLst>
                         <p:par>
@@ -16312,7 +16312,7 @@
                             </p:stCondLst>
                             <p:childTnLst>
                               <p:par>
-                                <p:cTn id="14" presetID="10" presetClass="entr" presetSubtype="0" fill="hold" grpId="0" nodeType="clickEffect">
+                                <p:cTn id="14" presetID="10" presetClass="entr" presetSubtype="0" fill="hold" grpId="0" nodeType="afterEffect">
                                   <p:stCondLst>
                                     <p:cond delay="0"/>
                                   </p:stCondLst>

</xml_diff>